<commit_message>
fix: adjust footer to 5.25in, move bottom cards up to prevent edge overflow
</commit_message>
<xml_diff>
--- a/docs/OfficeAI_项目汇报_v6.pptx
+++ b/docs/OfficeAI_项目汇报_v6.pptx
@@ -1689,8 +1689,8 @@
         </p:nvSpPr>
         <p:spPr>
           <a:xfrm>
-            <a:off x="0" y="4910328"/>
-            <a:ext cx="9144000" cy="233172"/>
+            <a:off x="0" y="4800600"/>
+            <a:ext cx="9144000" cy="342900"/>
           </a:xfrm>
           <a:prstGeom prst="rect">
             <a:avLst/>
@@ -1709,8 +1709,8 @@
         </p:nvSpPr>
         <p:spPr>
           <a:xfrm>
-            <a:off x="8229600" y="4910328"/>
-            <a:ext cx="640080" cy="233172"/>
+            <a:off x="8229600" y="4800600"/>
+            <a:ext cx="640080" cy="342900"/>
           </a:xfrm>
           <a:prstGeom prst="rect">
             <a:avLst/>
@@ -2228,8 +2228,8 @@
         </p:nvSpPr>
         <p:spPr>
           <a:xfrm>
-            <a:off x="457200" y="3931920"/>
-            <a:ext cx="2743200" cy="320040"/>
+            <a:off x="457200" y="3886200"/>
+            <a:ext cx="2743200" cy="274320"/>
           </a:xfrm>
           <a:prstGeom prst="rect">
             <a:avLst/>
@@ -2264,7 +2264,7 @@
         </p:nvSpPr>
         <p:spPr>
           <a:xfrm>
-            <a:off x="457200" y="4297680"/>
+            <a:off x="457200" y="4160520"/>
             <a:ext cx="8321040" cy="502920"/>
           </a:xfrm>
           <a:prstGeom prst="rect">
@@ -2291,7 +2291,7 @@
         </p:nvSpPr>
         <p:spPr>
           <a:xfrm>
-            <a:off x="640080" y="4297680"/>
+            <a:off x="640080" y="4160520"/>
             <a:ext cx="7955280" cy="502920"/>
           </a:xfrm>
           <a:prstGeom prst="rect">
@@ -2359,8 +2359,8 @@
         </p:nvSpPr>
         <p:spPr>
           <a:xfrm>
-            <a:off x="0" y="4910328"/>
-            <a:ext cx="9144000" cy="233172"/>
+            <a:off x="0" y="4800600"/>
+            <a:ext cx="9144000" cy="342900"/>
           </a:xfrm>
           <a:prstGeom prst="rect">
             <a:avLst/>
@@ -2379,8 +2379,8 @@
         </p:nvSpPr>
         <p:spPr>
           <a:xfrm>
-            <a:off x="8229600" y="4910328"/>
-            <a:ext cx="640080" cy="233172"/>
+            <a:off x="8229600" y="4800600"/>
+            <a:ext cx="640080" cy="342900"/>
           </a:xfrm>
           <a:prstGeom prst="rect">
             <a:avLst/>
@@ -2710,7 +2710,7 @@
         </p:nvSpPr>
         <p:spPr>
           <a:xfrm>
-            <a:off x="457200" y="3749040"/>
+            <a:off x="457200" y="3657600"/>
             <a:ext cx="3931920" cy="1005840"/>
           </a:xfrm>
           <a:prstGeom prst="rect">
@@ -3014,8 +3014,8 @@
         </p:nvSpPr>
         <p:spPr>
           <a:xfrm>
-            <a:off x="0" y="4910328"/>
-            <a:ext cx="9144000" cy="233172"/>
+            <a:off x="0" y="4800600"/>
+            <a:ext cx="9144000" cy="342900"/>
           </a:xfrm>
           <a:prstGeom prst="rect">
             <a:avLst/>
@@ -3034,8 +3034,8 @@
         </p:nvSpPr>
         <p:spPr>
           <a:xfrm>
-            <a:off x="8229600" y="4910328"/>
-            <a:ext cx="640080" cy="233172"/>
+            <a:off x="8229600" y="4800600"/>
+            <a:ext cx="640080" cy="342900"/>
           </a:xfrm>
           <a:prstGeom prst="rect">
             <a:avLst/>
@@ -3686,8 +3686,8 @@
         </p:nvSpPr>
         <p:spPr>
           <a:xfrm>
-            <a:off x="0" y="4910328"/>
-            <a:ext cx="9144000" cy="233172"/>
+            <a:off x="0" y="4800600"/>
+            <a:ext cx="9144000" cy="342900"/>
           </a:xfrm>
           <a:prstGeom prst="rect">
             <a:avLst/>
@@ -3706,8 +3706,8 @@
         </p:nvSpPr>
         <p:spPr>
           <a:xfrm>
-            <a:off x="8229600" y="4910328"/>
-            <a:ext cx="640080" cy="233172"/>
+            <a:off x="8229600" y="4800600"/>
+            <a:ext cx="640080" cy="342900"/>
           </a:xfrm>
           <a:prstGeom prst="rect">
             <a:avLst/>
@@ -4383,8 +4383,8 @@
         </p:nvSpPr>
         <p:spPr>
           <a:xfrm>
-            <a:off x="0" y="4910328"/>
-            <a:ext cx="9144000" cy="233172"/>
+            <a:off x="0" y="4800600"/>
+            <a:ext cx="9144000" cy="342900"/>
           </a:xfrm>
           <a:prstGeom prst="rect">
             <a:avLst/>
@@ -4403,8 +4403,8 @@
         </p:nvSpPr>
         <p:spPr>
           <a:xfrm>
-            <a:off x="8229600" y="4910328"/>
-            <a:ext cx="640080" cy="233172"/>
+            <a:off x="8229600" y="4800600"/>
+            <a:ext cx="640080" cy="342900"/>
           </a:xfrm>
           <a:prstGeom prst="rect">
             <a:avLst/>
@@ -5622,8 +5622,8 @@
         </p:nvSpPr>
         <p:spPr>
           <a:xfrm>
-            <a:off x="0" y="4910328"/>
-            <a:ext cx="9144000" cy="233172"/>
+            <a:off x="0" y="4800600"/>
+            <a:ext cx="9144000" cy="342900"/>
           </a:xfrm>
           <a:prstGeom prst="rect">
             <a:avLst/>
@@ -5642,8 +5642,8 @@
         </p:nvSpPr>
         <p:spPr>
           <a:xfrm>
-            <a:off x="8229600" y="4910328"/>
-            <a:ext cx="640080" cy="233172"/>
+            <a:off x="8229600" y="4800600"/>
+            <a:ext cx="640080" cy="342900"/>
           </a:xfrm>
           <a:prstGeom prst="rect">
             <a:avLst/>

</xml_diff>